<commit_message>
few updates in ppt
</commit_message>
<xml_diff>
--- a/Capstone PPT Template.pptx
+++ b/Capstone PPT Template.pptx
@@ -5,7 +5,7 @@
     <p:sldMasterId id="2147483648" r:id="rId1"/>
   </p:sldMasterIdLst>
   <p:notesMasterIdLst>
-    <p:notesMasterId r:id="rId14"/>
+    <p:notesMasterId r:id="rId15"/>
   </p:notesMasterIdLst>
   <p:sldIdLst>
     <p:sldId id="256" r:id="rId3"/>
@@ -15,11 +15,11 @@
     <p:sldId id="712" r:id="rId7"/>
     <p:sldId id="716" r:id="rId8"/>
     <p:sldId id="717" r:id="rId9"/>
-    <p:sldId id="718" r:id="rId10"/>
-    <p:sldId id="719" r:id="rId11"/>
-    <p:sldId id="720" r:id="rId18"/>
-    <p:sldId id="711" r:id="rId12"/>
-    <p:sldId id="303" r:id="rId13"/>
+    <p:sldId id="719" r:id="rId10"/>
+    <p:sldId id="718" r:id="rId11"/>
+    <p:sldId id="721" r:id="rId12"/>
+    <p:sldId id="711" r:id="rId13"/>
+    <p:sldId id="303" r:id="rId14"/>
   </p:sldIdLst>
   <p:sldSz cx="12192000" cy="6858000"/>
   <p:notesSz cx="6858000" cy="9144000"/>
@@ -4796,6 +4796,223 @@
         <p:cNvGrpSpPr/>
         <p:nvPr/>
       </p:nvGrpSpPr>
+      <p:grpSpPr/>
+      <p:sp>
+        <p:nvSpPr>
+          <p:cNvPr id="2" name="Content Placeholder 1"/>
+          <p:cNvSpPr>
+            <a:spLocks noGrp="1"/>
+          </p:cNvSpPr>
+          <p:nvPr>
+            <p:ph idx="1"/>
+          </p:nvPr>
+        </p:nvSpPr>
+        <p:spPr>
+          <a:xfrm>
+            <a:off x="4455160" y="145415"/>
+            <a:ext cx="7058025" cy="5912485"/>
+          </a:xfrm>
+        </p:spPr>
+        <p:txBody>
+          <a:bodyPr>
+            <a:normAutofit lnSpcReduction="10000"/>
+          </a:bodyPr>
+          <a:p>
+            <a:r>
+              <a:rPr lang="en-US" sz="2000"/>
+              <a:t>Real Data Layer - </a:t>
+            </a:r>
+            <a:endParaRPr lang="en-US" sz="2000"/>
+          </a:p>
+          <a:p>
+            <a:pPr marL="800100" lvl="1" indent="-342900"/>
+            <a:r>
+              <a:rPr lang="en-US" altLang="en-US" sz="1600"/>
+              <a:t>PostgreSQL/Supabase — real orders, real products, real inventory</a:t>
+            </a:r>
+            <a:endParaRPr lang="en-US" altLang="en-US" sz="1600"/>
+          </a:p>
+          <a:p>
+            <a:pPr marL="800100" lvl="1" indent="-342900"/>
+            <a:r>
+              <a:rPr lang="en-US" altLang="en-US" sz="1600"/>
+              <a:t>E-Commerce API Integration</a:t>
+            </a:r>
+            <a:endParaRPr lang="en-US" altLang="en-US" sz="1600"/>
+          </a:p>
+          <a:p>
+            <a:pPr marL="800100" lvl="1" indent="-342900"/>
+            <a:r>
+              <a:rPr lang="en-US" altLang="en-US" sz="1600"/>
+              <a:t>User Authentication</a:t>
+            </a:r>
+            <a:endParaRPr lang="en-US" altLang="en-US" sz="1600"/>
+          </a:p>
+          <a:p>
+            <a:pPr marL="800100" lvl="1" indent="-342900"/>
+            <a:r>
+              <a:rPr lang="en-US" altLang="en-US" sz="1600"/>
+              <a:t>Order Ownership</a:t>
+            </a:r>
+            <a:endParaRPr lang="en-US" altLang="en-US" sz="1600"/>
+          </a:p>
+          <a:p>
+            <a:r>
+              <a:rPr lang="en-US" sz="2000"/>
+              <a:t>Richer Voice Capabilities - </a:t>
+            </a:r>
+            <a:endParaRPr lang="en-US" sz="2000"/>
+          </a:p>
+          <a:p>
+            <a:pPr lvl="1"/>
+            <a:r>
+              <a:rPr lang="en-US" altLang="en-US" sz="1600"/>
+              <a:t>Multilingual Support</a:t>
+            </a:r>
+            <a:endParaRPr lang="en-US" altLang="en-US" sz="1600"/>
+          </a:p>
+          <a:p>
+            <a:pPr lvl="1"/>
+            <a:r>
+              <a:rPr lang="en-US" altLang="en-US" sz="1600"/>
+              <a:t>Barge-In Support</a:t>
+            </a:r>
+            <a:endParaRPr lang="en-US" altLang="en-US" sz="1600"/>
+          </a:p>
+          <a:p>
+            <a:pPr lvl="1"/>
+            <a:r>
+              <a:rPr lang="en-US" altLang="en-US" sz="1600"/>
+              <a:t>Custom brand voice</a:t>
+            </a:r>
+            <a:endParaRPr lang="en-US" altLang="en-US" sz="1600"/>
+          </a:p>
+          <a:p>
+            <a:pPr lvl="0"/>
+            <a:r>
+              <a:rPr lang="en-US" sz="2000"/>
+              <a:t>Smarter AI Layer</a:t>
+            </a:r>
+            <a:endParaRPr lang="en-US" sz="2000"/>
+          </a:p>
+          <a:p>
+            <a:pPr lvl="1"/>
+            <a:r>
+              <a:rPr lang="en-US" altLang="en-US" sz="1600"/>
+              <a:t>Vector-based RAG</a:t>
+            </a:r>
+            <a:endParaRPr lang="en-US" altLang="en-US" sz="1600"/>
+          </a:p>
+          <a:p>
+            <a:pPr lvl="1"/>
+            <a:r>
+              <a:rPr lang="en-US" altLang="en-US" sz="1600"/>
+              <a:t>Dynamic FAQ</a:t>
+            </a:r>
+            <a:endParaRPr lang="en-US" altLang="en-US" sz="1600"/>
+          </a:p>
+          <a:p>
+            <a:pPr lvl="1"/>
+            <a:r>
+              <a:rPr lang="en-US" altLang="en-US" sz="1600"/>
+              <a:t>Personalised Recommendation</a:t>
+            </a:r>
+            <a:endParaRPr lang="en-US" altLang="en-US" sz="1600"/>
+          </a:p>
+          <a:p>
+            <a:pPr lvl="1"/>
+            <a:r>
+              <a:rPr lang="en-US" altLang="en-US" sz="1600"/>
+              <a:t>Sentiment Detection</a:t>
+            </a:r>
+            <a:endParaRPr lang="en-US" altLang="en-US" sz="1600"/>
+          </a:p>
+          <a:p>
+            <a:pPr lvl="0"/>
+            <a:r>
+              <a:rPr lang="en-US" sz="2000"/>
+              <a:t>New Channels</a:t>
+            </a:r>
+            <a:endParaRPr lang="en-US" sz="2000"/>
+          </a:p>
+          <a:p>
+            <a:pPr lvl="1"/>
+            <a:r>
+              <a:rPr lang="en-US" sz="2000"/>
+              <a:t>Whatsapp Voice</a:t>
+            </a:r>
+            <a:endParaRPr lang="en-US" sz="2000"/>
+          </a:p>
+          <a:p>
+            <a:pPr lvl="1"/>
+            <a:r>
+              <a:rPr lang="en-US" sz="2000"/>
+              <a:t>Phone</a:t>
+            </a:r>
+            <a:endParaRPr lang="en-US" sz="2000"/>
+          </a:p>
+          <a:p>
+            <a:pPr lvl="1"/>
+            <a:r>
+              <a:rPr lang="en-US" sz="2000"/>
+              <a:t>Mobile App</a:t>
+            </a:r>
+            <a:endParaRPr lang="en-US" sz="2000"/>
+          </a:p>
+          <a:p>
+            <a:pPr lvl="1"/>
+            <a:r>
+              <a:rPr lang="en-US" sz="2000"/>
+              <a:t>Push Notification</a:t>
+            </a:r>
+            <a:endParaRPr lang="en-US" sz="2000"/>
+          </a:p>
+        </p:txBody>
+      </p:sp>
+      <p:sp>
+        <p:nvSpPr>
+          <p:cNvPr id="3" name="Title 2"/>
+          <p:cNvSpPr>
+            <a:spLocks noGrp="1"/>
+          </p:cNvSpPr>
+          <p:nvPr>
+            <p:ph type="title"/>
+          </p:nvPr>
+        </p:nvSpPr>
+        <p:spPr>
+          <a:xfrm>
+            <a:off x="0" y="2049780"/>
+            <a:ext cx="4088765" cy="2562225"/>
+          </a:xfrm>
+        </p:spPr>
+        <p:txBody>
+          <a:bodyPr/>
+          <a:p>
+            <a:r>
+              <a:rPr lang="en-US"/>
+              <a:t>Enhanacements</a:t>
+            </a:r>
+            <a:endParaRPr lang="en-US"/>
+          </a:p>
+        </p:txBody>
+      </p:sp>
+    </p:spTree>
+  </p:cSld>
+  <p:clrMapOvr>
+    <a:masterClrMapping/>
+  </p:clrMapOvr>
+</p:sld>
+</file>
+
+<file path=ppt/slides/slide11.xml><?xml version="1.0" encoding="utf-8"?>
+<p:sld xmlns:a="http://schemas.openxmlformats.org/drawingml/2006/main" xmlns:r="http://schemas.openxmlformats.org/officeDocument/2006/relationships" xmlns:p="http://schemas.openxmlformats.org/presentationml/2006/main">
+  <p:cSld>
+    <p:spTree>
+      <p:nvGrpSpPr>
+        <p:cNvPr id="1" name=""/>
+        <p:cNvGrpSpPr/>
+        <p:nvPr/>
+      </p:nvGrpSpPr>
       <p:grpSpPr>
         <a:xfrm>
           <a:off x="0" y="0"/>
@@ -4840,7 +5057,7 @@
 </p:sld>
 </file>
 
-<file path=ppt/slides/slide11.xml><?xml version="1.0" encoding="utf-8"?>
+<file path=ppt/slides/slide12.xml><?xml version="1.0" encoding="utf-8"?>
 <p:sld xmlns:a="http://schemas.openxmlformats.org/drawingml/2006/main" xmlns:r="http://schemas.openxmlformats.org/officeDocument/2006/relationships" xmlns:p="http://schemas.openxmlformats.org/presentationml/2006/main">
   <p:cSld>
     <p:spTree>
@@ -4906,861 +5123,6 @@
             <a:endParaRPr lang="en-IN" sz="6600" b="1" dirty="0">
               <a:latin typeface="Calibri" panose="020F0502020204030204" pitchFamily="34" charset="0"/>
             </a:endParaRPr>
-          </a:p>
-        </p:txBody>
-      </p:sp>
-    </p:spTree>
-  </p:cSld>
-  <p:clrMapOvr>
-    <a:masterClrMapping/>
-  </p:clrMapOvr>
-</p:sld>
-</file>
-
-<file path=ppt/slides/slide12.xml><?xml version="1.0" encoding="utf-8"?>
-<p:sld xmlns:a="http://schemas.openxmlformats.org/drawingml/2006/main" xmlns:p="http://schemas.openxmlformats.org/presentationml/2006/main" xmlns:r="http://schemas.openxmlformats.org/officeDocument/2006/relationships">
-  <p:cSld>
-    <p:bg>
-      <p:bgPr>
-        <a:solidFill>
-          <a:srgbClr val="F5F7FA"/>
-        </a:solidFill>
-        <a:effectLst/>
-      </p:bgPr>
-    </p:bg>
-    <p:spTree>
-      <p:nvGrpSpPr>
-        <p:cNvPr id="1" name=""/>
-        <p:cNvGrpSpPr/>
-        <p:nvPr/>
-      </p:nvGrpSpPr>
-      <p:grpSpPr/>
-      <p:sp>
-        <p:nvSpPr>
-          <p:cNvPr id="2" name="Title 1"/>
-          <p:cNvSpPr>
-            <a:spLocks noGrp="1"/>
-          </p:cNvSpPr>
-          <p:nvPr>
-            <p:ph type="title"/>
-          </p:nvPr>
-        </p:nvSpPr>
-        <p:spPr/>
-        <p:txBody>
-          <a:bodyPr/>
-          <a:lstStyle/>
-          <a:p/>
-        </p:txBody>
-      </p:sp>
-      <p:sp>
-        <p:nvSpPr>
-          <p:cNvPr id="3" name="Content Placeholder 2"/>
-          <p:cNvSpPr>
-            <a:spLocks noGrp="1"/>
-          </p:cNvSpPr>
-          <p:nvPr>
-            <p:ph idx="1"/>
-          </p:nvPr>
-        </p:nvSpPr>
-        <p:spPr/>
-        <p:txBody>
-          <a:bodyPr/>
-          <a:lstStyle/>
-          <a:p/>
-        </p:txBody>
-      </p:sp>
-      <p:sp>
-        <p:nvSpPr>
-          <p:cNvPr id="4" name="TextBox 3"/>
-          <p:cNvSpPr txBox="1"/>
-          <p:nvPr/>
-        </p:nvSpPr>
-        <p:spPr>
-          <a:xfrm>
-            <a:off x="502920" y="320040"/>
-            <a:ext cx="11155680" cy="640080"/>
-          </a:xfrm>
-          <a:prstGeom prst="rect">
-            <a:avLst/>
-          </a:prstGeom>
-          <a:noFill/>
-        </p:spPr>
-        <p:txBody>
-          <a:bodyPr wrap="none">
-            <a:spAutoFit/>
-          </a:bodyPr>
-          <a:lstStyle/>
-          <a:p>
-            <a:pPr>
-              <a:defRPr sz="3400" b="1">
-                <a:solidFill>
-                  <a:srgbClr val="172533"/>
-                </a:solidFill>
-              </a:defRPr>
-            </a:pPr>
-            <a:r>
-              <a:t>Next Steps for Enhancement</a:t>
-            </a:r>
-          </a:p>
-        </p:txBody>
-      </p:sp>
-      <p:sp>
-        <p:nvSpPr>
-          <p:cNvPr id="5" name="TextBox 4"/>
-          <p:cNvSpPr txBox="1"/>
-          <p:nvPr/>
-        </p:nvSpPr>
-        <p:spPr>
-          <a:xfrm>
-            <a:off x="530352" y="932688"/>
-            <a:ext cx="10881360" cy="320040"/>
-          </a:xfrm>
-          <a:prstGeom prst="rect">
-            <a:avLst/>
-          </a:prstGeom>
-          <a:noFill/>
-        </p:spPr>
-        <p:txBody>
-          <a:bodyPr wrap="none">
-            <a:spAutoFit/>
-          </a:bodyPr>
-          <a:lstStyle/>
-          <a:p>
-            <a:pPr>
-              <a:defRPr sz="1500">
-                <a:solidFill>
-                  <a:srgbClr val="526070"/>
-                </a:solidFill>
-              </a:defRPr>
-            </a:pPr>
-            <a:r>
-              <a:t>Moving VoxCart from capstone prototype to production-ready assistant</a:t>
-            </a:r>
-          </a:p>
-        </p:txBody>
-      </p:sp>
-      <p:sp>
-        <p:nvSpPr>
-          <p:cNvPr id="6" name="Rounded Rectangle 5"/>
-          <p:cNvSpPr/>
-          <p:nvPr/>
-        </p:nvSpPr>
-        <p:spPr>
-          <a:xfrm>
-            <a:off x="640080" y="1508760"/>
-            <a:ext cx="3611880" cy="1143000"/>
-          </a:xfrm>
-          <a:prstGeom prst="roundRect">
-            <a:avLst/>
-          </a:prstGeom>
-          <a:solidFill>
-            <a:srgbClr val="FFFFFF"/>
-          </a:solidFill>
-          <a:ln w="12700">
-            <a:solidFill>
-              <a:srgbClr val="D7DEE6"/>
-            </a:solidFill>
-          </a:ln>
-        </p:spPr>
-        <p:style>
-          <a:lnRef idx="1">
-            <a:schemeClr val="accent1"/>
-          </a:lnRef>
-          <a:fillRef idx="3">
-            <a:schemeClr val="accent1"/>
-          </a:fillRef>
-          <a:effectRef idx="2">
-            <a:schemeClr val="accent1"/>
-          </a:effectRef>
-          <a:fontRef idx="minor">
-            <a:schemeClr val="lt1"/>
-          </a:fontRef>
-        </p:style>
-        <p:txBody>
-          <a:bodyPr rtlCol="0" anchor="ctr" lIns="182880" rIns="128016" tIns="109728" bIns="73152"/>
-          <a:lstStyle/>
-          <a:p>
-            <a:pPr algn="ctr">
-              <a:spcAft>
-                <a:spcPts val="500"/>
-              </a:spcAft>
-              <a:defRPr sz="1400" b="1">
-                <a:solidFill>
-                  <a:srgbClr val="1E2C3A"/>
-                </a:solidFill>
-              </a:defRPr>
-            </a:pPr>
-            <a:r>
-              <a:t>Security &amp; Access</a:t>
-            </a:r>
-          </a:p>
-          <a:p>
-            <a:pPr>
-              <a:lnSpc>
-                <a:spcPct val="110000"/>
-              </a:lnSpc>
-              <a:defRPr sz="1050">
-                <a:solidFill>
-                  <a:srgbClr val="505B68"/>
-                </a:solidFill>
-              </a:defRPr>
-            </a:pPr>
-            <a:r>
-              <a:t>Authenticate users before token minting; restrict CORS; add rate limits.</a:t>
-            </a:r>
-          </a:p>
-        </p:txBody>
-      </p:sp>
-      <p:sp>
-        <p:nvSpPr>
-          <p:cNvPr id="7" name="Rectangle 6"/>
-          <p:cNvSpPr/>
-          <p:nvPr/>
-        </p:nvSpPr>
-        <p:spPr>
-          <a:xfrm>
-            <a:off x="640080" y="1508760"/>
-            <a:ext cx="73152" cy="1143000"/>
-          </a:xfrm>
-          <a:prstGeom prst="rect">
-            <a:avLst/>
-          </a:prstGeom>
-          <a:solidFill>
-            <a:srgbClr val="2A548C"/>
-          </a:solidFill>
-          <a:ln>
-            <a:noFill/>
-          </a:ln>
-        </p:spPr>
-        <p:style>
-          <a:lnRef idx="1">
-            <a:schemeClr val="accent1"/>
-          </a:lnRef>
-          <a:fillRef idx="3">
-            <a:schemeClr val="accent1"/>
-          </a:fillRef>
-          <a:effectRef idx="2">
-            <a:schemeClr val="accent1"/>
-          </a:effectRef>
-          <a:fontRef idx="minor">
-            <a:schemeClr val="lt1"/>
-          </a:fontRef>
-        </p:style>
-        <p:txBody>
-          <a:bodyPr rtlCol="0" anchor="ctr"/>
-          <a:lstStyle/>
-          <a:p>
-            <a:pPr algn="ctr"/>
-          </a:p>
-        </p:txBody>
-      </p:sp>
-      <p:sp>
-        <p:nvSpPr>
-          <p:cNvPr id="8" name="Rounded Rectangle 7"/>
-          <p:cNvSpPr/>
-          <p:nvPr/>
-        </p:nvSpPr>
-        <p:spPr>
-          <a:xfrm>
-            <a:off x="4526280" y="1508760"/>
-            <a:ext cx="3611880" cy="1143000"/>
-          </a:xfrm>
-          <a:prstGeom prst="roundRect">
-            <a:avLst/>
-          </a:prstGeom>
-          <a:solidFill>
-            <a:srgbClr val="FFFFFF"/>
-          </a:solidFill>
-          <a:ln w="12700">
-            <a:solidFill>
-              <a:srgbClr val="D7DEE6"/>
-            </a:solidFill>
-          </a:ln>
-        </p:spPr>
-        <p:style>
-          <a:lnRef idx="1">
-            <a:schemeClr val="accent1"/>
-          </a:lnRef>
-          <a:fillRef idx="3">
-            <a:schemeClr val="accent1"/>
-          </a:fillRef>
-          <a:effectRef idx="2">
-            <a:schemeClr val="accent1"/>
-          </a:effectRef>
-          <a:fontRef idx="minor">
-            <a:schemeClr val="lt1"/>
-          </a:fontRef>
-        </p:style>
-        <p:txBody>
-          <a:bodyPr rtlCol="0" anchor="ctr" lIns="182880" rIns="128016" tIns="109728" bIns="73152"/>
-          <a:lstStyle/>
-          <a:p>
-            <a:pPr algn="ctr">
-              <a:spcAft>
-                <a:spcPts val="500"/>
-              </a:spcAft>
-              <a:defRPr sz="1400" b="1">
-                <a:solidFill>
-                  <a:srgbClr val="1E2C3A"/>
-                </a:solidFill>
-              </a:defRPr>
-            </a:pPr>
-            <a:r>
-              <a:t>Order Ownership</a:t>
-            </a:r>
-          </a:p>
-          <a:p>
-            <a:pPr>
-              <a:lnSpc>
-                <a:spcPct val="110000"/>
-              </a:lnSpc>
-              <a:defRPr sz="1050">
-                <a:solidFill>
-                  <a:srgbClr val="505B68"/>
-                </a:solidFill>
-              </a:defRPr>
-            </a:pPr>
-            <a:r>
-              <a:t>Verify that a user can access only their own orders before returning status.</a:t>
-            </a:r>
-          </a:p>
-        </p:txBody>
-      </p:sp>
-      <p:sp>
-        <p:nvSpPr>
-          <p:cNvPr id="9" name="Rectangle 8"/>
-          <p:cNvSpPr/>
-          <p:nvPr/>
-        </p:nvSpPr>
-        <p:spPr>
-          <a:xfrm>
-            <a:off x="4526280" y="1508760"/>
-            <a:ext cx="73152" cy="1143000"/>
-          </a:xfrm>
-          <a:prstGeom prst="rect">
-            <a:avLst/>
-          </a:prstGeom>
-          <a:solidFill>
-            <a:srgbClr val="1C7A68"/>
-          </a:solidFill>
-          <a:ln>
-            <a:noFill/>
-          </a:ln>
-        </p:spPr>
-        <p:style>
-          <a:lnRef idx="1">
-            <a:schemeClr val="accent1"/>
-          </a:lnRef>
-          <a:fillRef idx="3">
-            <a:schemeClr val="accent1"/>
-          </a:fillRef>
-          <a:effectRef idx="2">
-            <a:schemeClr val="accent1"/>
-          </a:effectRef>
-          <a:fontRef idx="minor">
-            <a:schemeClr val="lt1"/>
-          </a:fontRef>
-        </p:style>
-        <p:txBody>
-          <a:bodyPr rtlCol="0" anchor="ctr"/>
-          <a:lstStyle/>
-          <a:p>
-            <a:pPr algn="ctr"/>
-          </a:p>
-        </p:txBody>
-      </p:sp>
-      <p:sp>
-        <p:nvSpPr>
-          <p:cNvPr id="10" name="Rounded Rectangle 9"/>
-          <p:cNvSpPr/>
-          <p:nvPr/>
-        </p:nvSpPr>
-        <p:spPr>
-          <a:xfrm>
-            <a:off x="8412480" y="1508760"/>
-            <a:ext cx="3611880" cy="1143000"/>
-          </a:xfrm>
-          <a:prstGeom prst="roundRect">
-            <a:avLst/>
-          </a:prstGeom>
-          <a:solidFill>
-            <a:srgbClr val="FFFFFF"/>
-          </a:solidFill>
-          <a:ln w="12700">
-            <a:solidFill>
-              <a:srgbClr val="D7DEE6"/>
-            </a:solidFill>
-          </a:ln>
-        </p:spPr>
-        <p:style>
-          <a:lnRef idx="1">
-            <a:schemeClr val="accent1"/>
-          </a:lnRef>
-          <a:fillRef idx="3">
-            <a:schemeClr val="accent1"/>
-          </a:fillRef>
-          <a:effectRef idx="2">
-            <a:schemeClr val="accent1"/>
-          </a:effectRef>
-          <a:fontRef idx="minor">
-            <a:schemeClr val="lt1"/>
-          </a:fontRef>
-        </p:style>
-        <p:txBody>
-          <a:bodyPr rtlCol="0" anchor="ctr" lIns="182880" rIns="128016" tIns="109728" bIns="73152"/>
-          <a:lstStyle/>
-          <a:p>
-            <a:pPr algn="ctr">
-              <a:spcAft>
-                <a:spcPts val="500"/>
-              </a:spcAft>
-              <a:defRPr sz="1400" b="1">
-                <a:solidFill>
-                  <a:srgbClr val="1E2C3A"/>
-                </a:solidFill>
-              </a:defRPr>
-            </a:pPr>
-            <a:r>
-              <a:t>Safety Guardrails</a:t>
-            </a:r>
-          </a:p>
-          <a:p>
-            <a:pPr>
-              <a:lnSpc>
-                <a:spcPct val="110000"/>
-              </a:lnSpc>
-              <a:defRPr sz="1050">
-                <a:solidFill>
-                  <a:srgbClr val="505B68"/>
-                </a:solidFill>
-              </a:defRPr>
-            </a:pPr>
-            <a:r>
-              <a:t>Add moderation, prompt-injection checks, and response validation.</a:t>
-            </a:r>
-          </a:p>
-        </p:txBody>
-      </p:sp>
-      <p:sp>
-        <p:nvSpPr>
-          <p:cNvPr id="11" name="Rectangle 10"/>
-          <p:cNvSpPr/>
-          <p:nvPr/>
-        </p:nvSpPr>
-        <p:spPr>
-          <a:xfrm>
-            <a:off x="8412480" y="1508760"/>
-            <a:ext cx="73152" cy="1143000"/>
-          </a:xfrm>
-          <a:prstGeom prst="rect">
-            <a:avLst/>
-          </a:prstGeom>
-          <a:solidFill>
-            <a:srgbClr val="955029"/>
-          </a:solidFill>
-          <a:ln>
-            <a:noFill/>
-          </a:ln>
-        </p:spPr>
-        <p:style>
-          <a:lnRef idx="1">
-            <a:schemeClr val="accent1"/>
-          </a:lnRef>
-          <a:fillRef idx="3">
-            <a:schemeClr val="accent1"/>
-          </a:fillRef>
-          <a:effectRef idx="2">
-            <a:schemeClr val="accent1"/>
-          </a:effectRef>
-          <a:fontRef idx="minor">
-            <a:schemeClr val="lt1"/>
-          </a:fontRef>
-        </p:style>
-        <p:txBody>
-          <a:bodyPr rtlCol="0" anchor="ctr"/>
-          <a:lstStyle/>
-          <a:p>
-            <a:pPr algn="ctr"/>
-          </a:p>
-        </p:txBody>
-      </p:sp>
-      <p:sp>
-        <p:nvSpPr>
-          <p:cNvPr id="12" name="Rounded Rectangle 11"/>
-          <p:cNvSpPr/>
-          <p:nvPr/>
-        </p:nvSpPr>
-        <p:spPr>
-          <a:xfrm>
-            <a:off x="640080" y="2944368"/>
-            <a:ext cx="3611880" cy="1143000"/>
-          </a:xfrm>
-          <a:prstGeom prst="roundRect">
-            <a:avLst/>
-          </a:prstGeom>
-          <a:solidFill>
-            <a:srgbClr val="FFFFFF"/>
-          </a:solidFill>
-          <a:ln w="12700">
-            <a:solidFill>
-              <a:srgbClr val="D7DEE6"/>
-            </a:solidFill>
-          </a:ln>
-        </p:spPr>
-        <p:style>
-          <a:lnRef idx="1">
-            <a:schemeClr val="accent1"/>
-          </a:lnRef>
-          <a:fillRef idx="3">
-            <a:schemeClr val="accent1"/>
-          </a:fillRef>
-          <a:effectRef idx="2">
-            <a:schemeClr val="accent1"/>
-          </a:effectRef>
-          <a:fontRef idx="minor">
-            <a:schemeClr val="lt1"/>
-          </a:fontRef>
-        </p:style>
-        <p:txBody>
-          <a:bodyPr rtlCol="0" anchor="ctr" lIns="182880" rIns="128016" tIns="109728" bIns="73152"/>
-          <a:lstStyle/>
-          <a:p>
-            <a:pPr algn="ctr">
-              <a:spcAft>
-                <a:spcPts val="500"/>
-              </a:spcAft>
-              <a:defRPr sz="1400" b="1">
-                <a:solidFill>
-                  <a:srgbClr val="1E2C3A"/>
-                </a:solidFill>
-              </a:defRPr>
-            </a:pPr>
-            <a:r>
-              <a:t>Real Backend</a:t>
-            </a:r>
-          </a:p>
-          <a:p>
-            <a:pPr>
-              <a:lnSpc>
-                <a:spcPct val="110000"/>
-              </a:lnSpc>
-              <a:defRPr sz="1050">
-                <a:solidFill>
-                  <a:srgbClr val="505B68"/>
-                </a:solidFill>
-              </a:defRPr>
-            </a:pPr>
-            <a:r>
-              <a:t>Replace mock data with live catalogue, order, return, and payment APIs.</a:t>
-            </a:r>
-          </a:p>
-        </p:txBody>
-      </p:sp>
-      <p:sp>
-        <p:nvSpPr>
-          <p:cNvPr id="13" name="Rectangle 12"/>
-          <p:cNvSpPr/>
-          <p:nvPr/>
-        </p:nvSpPr>
-        <p:spPr>
-          <a:xfrm>
-            <a:off x="640080" y="2944368"/>
-            <a:ext cx="73152" cy="1143000"/>
-          </a:xfrm>
-          <a:prstGeom prst="rect">
-            <a:avLst/>
-          </a:prstGeom>
-          <a:solidFill>
-            <a:srgbClr val="6958A6"/>
-          </a:solidFill>
-          <a:ln>
-            <a:noFill/>
-          </a:ln>
-        </p:spPr>
-        <p:style>
-          <a:lnRef idx="1">
-            <a:schemeClr val="accent1"/>
-          </a:lnRef>
-          <a:fillRef idx="3">
-            <a:schemeClr val="accent1"/>
-          </a:fillRef>
-          <a:effectRef idx="2">
-            <a:schemeClr val="accent1"/>
-          </a:effectRef>
-          <a:fontRef idx="minor">
-            <a:schemeClr val="lt1"/>
-          </a:fontRef>
-        </p:style>
-        <p:txBody>
-          <a:bodyPr rtlCol="0" anchor="ctr"/>
-          <a:lstStyle/>
-          <a:p>
-            <a:pPr algn="ctr"/>
-          </a:p>
-        </p:txBody>
-      </p:sp>
-      <p:sp>
-        <p:nvSpPr>
-          <p:cNvPr id="14" name="Rounded Rectangle 13"/>
-          <p:cNvSpPr/>
-          <p:nvPr/>
-        </p:nvSpPr>
-        <p:spPr>
-          <a:xfrm>
-            <a:off x="4526280" y="2944368"/>
-            <a:ext cx="3611880" cy="1143000"/>
-          </a:xfrm>
-          <a:prstGeom prst="roundRect">
-            <a:avLst/>
-          </a:prstGeom>
-          <a:solidFill>
-            <a:srgbClr val="FFFFFF"/>
-          </a:solidFill>
-          <a:ln w="12700">
-            <a:solidFill>
-              <a:srgbClr val="D7DEE6"/>
-            </a:solidFill>
-          </a:ln>
-        </p:spPr>
-        <p:style>
-          <a:lnRef idx="1">
-            <a:schemeClr val="accent1"/>
-          </a:lnRef>
-          <a:fillRef idx="3">
-            <a:schemeClr val="accent1"/>
-          </a:fillRef>
-          <a:effectRef idx="2">
-            <a:schemeClr val="accent1"/>
-          </a:effectRef>
-          <a:fontRef idx="minor">
-            <a:schemeClr val="lt1"/>
-          </a:fontRef>
-        </p:style>
-        <p:txBody>
-          <a:bodyPr rtlCol="0" anchor="ctr" lIns="182880" rIns="128016" tIns="109728" bIns="73152"/>
-          <a:lstStyle/>
-          <a:p>
-            <a:pPr algn="ctr">
-              <a:spcAft>
-                <a:spcPts val="500"/>
-              </a:spcAft>
-              <a:defRPr sz="1400" b="1">
-                <a:solidFill>
-                  <a:srgbClr val="1E2C3A"/>
-                </a:solidFill>
-              </a:defRPr>
-            </a:pPr>
-            <a:r>
-              <a:t>Quality Metrics</a:t>
-            </a:r>
-          </a:p>
-          <a:p>
-            <a:pPr>
-              <a:lnSpc>
-                <a:spcPct val="110000"/>
-              </a:lnSpc>
-              <a:defRPr sz="1050">
-                <a:solidFill>
-                  <a:srgbClr val="505B68"/>
-                </a:solidFill>
-              </a:defRPr>
-            </a:pPr>
-            <a:r>
-              <a:t>Track latency, tool accuracy, fallback rate, and task completion.</a:t>
-            </a:r>
-          </a:p>
-        </p:txBody>
-      </p:sp>
-      <p:sp>
-        <p:nvSpPr>
-          <p:cNvPr id="15" name="Rectangle 14"/>
-          <p:cNvSpPr/>
-          <p:nvPr/>
-        </p:nvSpPr>
-        <p:spPr>
-          <a:xfrm>
-            <a:off x="4526280" y="2944368"/>
-            <a:ext cx="73152" cy="1143000"/>
-          </a:xfrm>
-          <a:prstGeom prst="rect">
-            <a:avLst/>
-          </a:prstGeom>
-          <a:solidFill>
-            <a:srgbClr val="A13946"/>
-          </a:solidFill>
-          <a:ln>
-            <a:noFill/>
-          </a:ln>
-        </p:spPr>
-        <p:style>
-          <a:lnRef idx="1">
-            <a:schemeClr val="accent1"/>
-          </a:lnRef>
-          <a:fillRef idx="3">
-            <a:schemeClr val="accent1"/>
-          </a:fillRef>
-          <a:effectRef idx="2">
-            <a:schemeClr val="accent1"/>
-          </a:effectRef>
-          <a:fontRef idx="minor">
-            <a:schemeClr val="lt1"/>
-          </a:fontRef>
-        </p:style>
-        <p:txBody>
-          <a:bodyPr rtlCol="0" anchor="ctr"/>
-          <a:lstStyle/>
-          <a:p>
-            <a:pPr algn="ctr"/>
-          </a:p>
-        </p:txBody>
-      </p:sp>
-      <p:sp>
-        <p:nvSpPr>
-          <p:cNvPr id="16" name="Rounded Rectangle 15"/>
-          <p:cNvSpPr/>
-          <p:nvPr/>
-        </p:nvSpPr>
-        <p:spPr>
-          <a:xfrm>
-            <a:off x="8412480" y="2944368"/>
-            <a:ext cx="3611880" cy="1143000"/>
-          </a:xfrm>
-          <a:prstGeom prst="roundRect">
-            <a:avLst/>
-          </a:prstGeom>
-          <a:solidFill>
-            <a:srgbClr val="FFFFFF"/>
-          </a:solidFill>
-          <a:ln w="12700">
-            <a:solidFill>
-              <a:srgbClr val="D7DEE6"/>
-            </a:solidFill>
-          </a:ln>
-        </p:spPr>
-        <p:style>
-          <a:lnRef idx="1">
-            <a:schemeClr val="accent1"/>
-          </a:lnRef>
-          <a:fillRef idx="3">
-            <a:schemeClr val="accent1"/>
-          </a:fillRef>
-          <a:effectRef idx="2">
-            <a:schemeClr val="accent1"/>
-          </a:effectRef>
-          <a:fontRef idx="minor">
-            <a:schemeClr val="lt1"/>
-          </a:fontRef>
-        </p:style>
-        <p:txBody>
-          <a:bodyPr rtlCol="0" anchor="ctr" lIns="182880" rIns="128016" tIns="109728" bIns="73152"/>
-          <a:lstStyle/>
-          <a:p>
-            <a:pPr algn="ctr">
-              <a:spcAft>
-                <a:spcPts val="500"/>
-              </a:spcAft>
-              <a:defRPr sz="1400" b="1">
-                <a:solidFill>
-                  <a:srgbClr val="1E2C3A"/>
-                </a:solidFill>
-              </a:defRPr>
-            </a:pPr>
-            <a:r>
-              <a:t>Multilingual Scale</a:t>
-            </a:r>
-          </a:p>
-          <a:p>
-            <a:pPr>
-              <a:lnSpc>
-                <a:spcPct val="110000"/>
-              </a:lnSpc>
-              <a:defRPr sz="1050">
-                <a:solidFill>
-                  <a:srgbClr val="505B68"/>
-                </a:solidFill>
-              </a:defRPr>
-            </a:pPr>
-            <a:r>
-              <a:t>Validate STT/TTS quality across languages, accents, and noisy settings.</a:t>
-            </a:r>
-          </a:p>
-        </p:txBody>
-      </p:sp>
-      <p:sp>
-        <p:nvSpPr>
-          <p:cNvPr id="17" name="Rectangle 16"/>
-          <p:cNvSpPr/>
-          <p:nvPr/>
-        </p:nvSpPr>
-        <p:spPr>
-          <a:xfrm>
-            <a:off x="8412480" y="2944368"/>
-            <a:ext cx="73152" cy="1143000"/>
-          </a:xfrm>
-          <a:prstGeom prst="rect">
-            <a:avLst/>
-          </a:prstGeom>
-          <a:solidFill>
-            <a:srgbClr val="4D6836"/>
-          </a:solidFill>
-          <a:ln>
-            <a:noFill/>
-          </a:ln>
-        </p:spPr>
-        <p:style>
-          <a:lnRef idx="1">
-            <a:schemeClr val="accent1"/>
-          </a:lnRef>
-          <a:fillRef idx="3">
-            <a:schemeClr val="accent1"/>
-          </a:fillRef>
-          <a:effectRef idx="2">
-            <a:schemeClr val="accent1"/>
-          </a:effectRef>
-          <a:fontRef idx="minor">
-            <a:schemeClr val="lt1"/>
-          </a:fontRef>
-        </p:style>
-        <p:txBody>
-          <a:bodyPr rtlCol="0" anchor="ctr"/>
-          <a:lstStyle/>
-          <a:p>
-            <a:pPr algn="ctr"/>
-          </a:p>
-        </p:txBody>
-      </p:sp>
-      <p:sp>
-        <p:nvSpPr>
-          <p:cNvPr id="18" name="TextBox 17"/>
-          <p:cNvSpPr txBox="1"/>
-          <p:nvPr/>
-        </p:nvSpPr>
-        <p:spPr>
-          <a:xfrm>
-            <a:off x="594360" y="6172200"/>
-            <a:ext cx="10972800" cy="320040"/>
-          </a:xfrm>
-          <a:prstGeom prst="rect">
-            <a:avLst/>
-          </a:prstGeom>
-          <a:noFill/>
-        </p:spPr>
-        <p:txBody>
-          <a:bodyPr wrap="none">
-            <a:spAutoFit/>
-          </a:bodyPr>
-          <a:lstStyle/>
-          <a:p>
-            <a:pPr algn="ctr">
-              <a:defRPr sz="1300">
-                <a:solidFill>
-                  <a:srgbClr val="4A5562"/>
-                </a:solidFill>
-              </a:defRPr>
-            </a:pPr>
-            <a:r>
-              <a:t>Immediate demo readiness: run healthcheck, verify microphone permissions, and rehearse the three required voice scenarios.</a:t>
-            </a:r>
           </a:p>
         </p:txBody>
       </p:sp>
@@ -8276,6 +7638,173 @@
         <p:nvPr/>
       </p:nvGrpSpPr>
       <p:grpSpPr/>
+      <p:sp>
+        <p:nvSpPr>
+          <p:cNvPr id="5" name="Title 4"/>
+          <p:cNvSpPr>
+            <a:spLocks noGrp="1"/>
+          </p:cNvSpPr>
+          <p:nvPr>
+            <p:ph type="title"/>
+          </p:nvPr>
+        </p:nvSpPr>
+        <p:spPr>
+          <a:xfrm>
+            <a:off x="635" y="2049780"/>
+            <a:ext cx="4092575" cy="2562225"/>
+          </a:xfrm>
+        </p:spPr>
+        <p:txBody>
+          <a:bodyPr/>
+          <a:p>
+            <a:r>
+              <a:rPr lang="en-US" altLang="en-US"/>
+              <a:t>Demo</a:t>
+            </a:r>
+            <a:br>
+              <a:rPr lang="en-US" altLang="en-US"/>
+            </a:br>
+            <a:endParaRPr lang="en-US" altLang="en-US"/>
+          </a:p>
+        </p:txBody>
+      </p:sp>
+      <p:sp>
+        <p:nvSpPr>
+          <p:cNvPr id="2" name="Content Placeholder 1"/>
+          <p:cNvSpPr/>
+          <p:nvPr>
+            <p:ph idx="1"/>
+          </p:nvPr>
+        </p:nvSpPr>
+        <p:spPr>
+          <a:xfrm>
+            <a:off x="4455160" y="136525"/>
+            <a:ext cx="7627620" cy="5877560"/>
+          </a:xfrm>
+        </p:spPr>
+        <p:txBody>
+          <a:bodyPr>
+            <a:normAutofit/>
+          </a:bodyPr>
+          <a:p>
+            <a:r>
+              <a:rPr lang="en-US" altLang="en-US" sz="1800"/>
+              <a:t>Scenario 1:</a:t>
+            </a:r>
+            <a:endParaRPr lang="en-US" altLang="en-US" sz="1800"/>
+          </a:p>
+          <a:p>
+            <a:pPr marL="0" indent="0">
+              <a:buNone/>
+            </a:pPr>
+            <a:r>
+              <a:rPr lang="en-US" altLang="en-US" sz="1800">
+                <a:sym typeface="+mn-ea"/>
+              </a:rPr>
+              <a:t>”</a:t>
+            </a:r>
+            <a:r>
+              <a:rPr lang="en-US" altLang="en-US" sz="1800"/>
+              <a:t> Hi, what's the status of my order ORD-1003?"</a:t>
+            </a:r>
+            <a:endParaRPr lang="en-US" altLang="en-US" sz="1800"/>
+          </a:p>
+          <a:p>
+            <a:pPr marL="0" indent="0">
+              <a:buNone/>
+            </a:pPr>
+            <a:r>
+              <a:rPr lang="en-US" altLang="en-US" sz="1800"/>
+              <a:t>→ Aria calls get_order_status, returns: "Your order for [items] has been shipped. Expected delivery by [date]. Tracking number: [0RD- 1003]."</a:t>
+            </a:r>
+            <a:endParaRPr lang="en-US" altLang="en-US" sz="1800"/>
+          </a:p>
+          <a:p>
+            <a:endParaRPr lang="en-US" altLang="en-US" sz="1800"/>
+          </a:p>
+          <a:p>
+            <a:r>
+              <a:rPr lang="en-US" altLang="en-US" sz="1800"/>
+              <a:t>Scenario 2:</a:t>
+            </a:r>
+            <a:endParaRPr lang="en-US" altLang="en-US" sz="1800"/>
+          </a:p>
+          <a:p>
+            <a:pPr marL="0" indent="0">
+              <a:buNone/>
+            </a:pPr>
+            <a:r>
+              <a:rPr lang="en-US" altLang="en-US" sz="1800"/>
+              <a:t>"Do you have Sony headphones? What's the price?"</a:t>
+            </a:r>
+            <a:endParaRPr lang="en-US" altLang="en-US" sz="1800"/>
+          </a:p>
+          <a:p>
+            <a:pPr marL="0" indent="0">
+              <a:buNone/>
+            </a:pPr>
+            <a:r>
+              <a:rPr lang="en-US" altLang="en-US" sz="1800"/>
+              <a:t>→ Aria calls lookup_product, returns price, rating, stock status, top 3 features.</a:t>
+            </a:r>
+            <a:endParaRPr lang="en-US" altLang="en-US" sz="1800"/>
+          </a:p>
+          <a:p>
+            <a:pPr marL="0" indent="0">
+              <a:buNone/>
+            </a:pPr>
+            <a:endParaRPr lang="en-US" altLang="en-US" sz="1800"/>
+          </a:p>
+          <a:p>
+            <a:pPr marL="0" indent="0">
+              <a:buNone/>
+            </a:pPr>
+            <a:r>
+              <a:rPr lang="en-US" altLang="en-US" sz="1800"/>
+              <a:t>Scenario 3:</a:t>
+            </a:r>
+            <a:endParaRPr lang="en-US" altLang="en-US" sz="1800"/>
+          </a:p>
+          <a:p>
+            <a:pPr marL="0" indent="0">
+              <a:buNone/>
+            </a:pPr>
+            <a:r>
+              <a:rPr lang="en-US" altLang="en-US" sz="1800"/>
+              <a:t>"I want to return a jacket I bought last week."</a:t>
+            </a:r>
+            <a:endParaRPr lang="en-US" altLang="en-US" sz="1800"/>
+          </a:p>
+          <a:p>
+            <a:pPr marL="0" indent="0">
+              <a:buNone/>
+            </a:pPr>
+            <a:r>
+              <a:rPr lang="en-US" altLang="en-US" sz="1800"/>
+              <a:t>→ Aria calls get_returns_policy, returns the Clothing return window (30 days) and steps to initiate.</a:t>
+            </a:r>
+            <a:endParaRPr lang="en-US" altLang="en-US" sz="1800"/>
+          </a:p>
+        </p:txBody>
+      </p:sp>
+    </p:spTree>
+  </p:cSld>
+  <p:clrMapOvr>
+    <a:masterClrMapping/>
+  </p:clrMapOvr>
+</p:sld>
+</file>
+
+<file path=ppt/slides/slide9.xml><?xml version="1.0" encoding="utf-8"?>
+<p:sld xmlns:a="http://schemas.openxmlformats.org/drawingml/2006/main" xmlns:r="http://schemas.openxmlformats.org/officeDocument/2006/relationships" xmlns:p="http://schemas.openxmlformats.org/presentationml/2006/main">
+  <p:cSld>
+    <p:spTree>
+      <p:nvGrpSpPr>
+        <p:cNvPr id="1" name=""/>
+        <p:cNvGrpSpPr/>
+        <p:nvPr/>
+      </p:nvGrpSpPr>
+      <p:grpSpPr/>
       <p:graphicFrame>
         <p:nvGraphicFramePr>
           <p:cNvPr id="6" name="Content Placeholder 5"/>
@@ -8627,173 +8156,6 @@
               <a:t>Challenges &amp; Solutions</a:t>
             </a:r>
             <a:endParaRPr lang="en-US" altLang="en-US"/>
-          </a:p>
-        </p:txBody>
-      </p:sp>
-    </p:spTree>
-  </p:cSld>
-  <p:clrMapOvr>
-    <a:masterClrMapping/>
-  </p:clrMapOvr>
-</p:sld>
-</file>
-
-<file path=ppt/slides/slide9.xml><?xml version="1.0" encoding="utf-8"?>
-<p:sld xmlns:a="http://schemas.openxmlformats.org/drawingml/2006/main" xmlns:r="http://schemas.openxmlformats.org/officeDocument/2006/relationships" xmlns:p="http://schemas.openxmlformats.org/presentationml/2006/main">
-  <p:cSld>
-    <p:spTree>
-      <p:nvGrpSpPr>
-        <p:cNvPr id="1" name=""/>
-        <p:cNvGrpSpPr/>
-        <p:nvPr/>
-      </p:nvGrpSpPr>
-      <p:grpSpPr/>
-      <p:sp>
-        <p:nvSpPr>
-          <p:cNvPr id="5" name="Title 4"/>
-          <p:cNvSpPr>
-            <a:spLocks noGrp="1"/>
-          </p:cNvSpPr>
-          <p:nvPr>
-            <p:ph type="title"/>
-          </p:nvPr>
-        </p:nvSpPr>
-        <p:spPr>
-          <a:xfrm>
-            <a:off x="635" y="2049780"/>
-            <a:ext cx="4092575" cy="2562225"/>
-          </a:xfrm>
-        </p:spPr>
-        <p:txBody>
-          <a:bodyPr/>
-          <a:p>
-            <a:r>
-              <a:rPr lang="en-US" altLang="en-US"/>
-              <a:t>Demo</a:t>
-            </a:r>
-            <a:br>
-              <a:rPr lang="en-US" altLang="en-US"/>
-            </a:br>
-            <a:endParaRPr lang="en-US" altLang="en-US"/>
-          </a:p>
-        </p:txBody>
-      </p:sp>
-      <p:sp>
-        <p:nvSpPr>
-          <p:cNvPr id="2" name="Content Placeholder 1"/>
-          <p:cNvSpPr/>
-          <p:nvPr>
-            <p:ph idx="1"/>
-          </p:nvPr>
-        </p:nvSpPr>
-        <p:spPr>
-          <a:xfrm>
-            <a:off x="4455160" y="136525"/>
-            <a:ext cx="7627620" cy="5877560"/>
-          </a:xfrm>
-        </p:spPr>
-        <p:txBody>
-          <a:bodyPr>
-            <a:normAutofit/>
-          </a:bodyPr>
-          <a:p>
-            <a:r>
-              <a:rPr lang="en-US" altLang="en-US" sz="1800"/>
-              <a:t>Scenario 1:</a:t>
-            </a:r>
-            <a:endParaRPr lang="en-US" altLang="en-US" sz="1800"/>
-          </a:p>
-          <a:p>
-            <a:pPr marL="0" indent="0">
-              <a:buNone/>
-            </a:pPr>
-            <a:r>
-              <a:rPr lang="en-US" altLang="en-US" sz="1800">
-                <a:sym typeface="+mn-ea"/>
-              </a:rPr>
-              <a:t>”</a:t>
-            </a:r>
-            <a:r>
-              <a:rPr lang="en-US" altLang="en-US" sz="1800"/>
-              <a:t> Hi, what's the status of my order ORD-1003?"</a:t>
-            </a:r>
-            <a:endParaRPr lang="en-US" altLang="en-US" sz="1800"/>
-          </a:p>
-          <a:p>
-            <a:pPr marL="0" indent="0">
-              <a:buNone/>
-            </a:pPr>
-            <a:r>
-              <a:rPr lang="en-US" altLang="en-US" sz="1800"/>
-              <a:t>→ Aria calls get_order_status, returns: "Your order for [items] has been shipped. Expected delivery by [date]. Tracking number: [TRK-xxx]."</a:t>
-            </a:r>
-            <a:endParaRPr lang="en-US" altLang="en-US" sz="1800"/>
-          </a:p>
-          <a:p>
-            <a:endParaRPr lang="en-US" altLang="en-US" sz="1800"/>
-          </a:p>
-          <a:p>
-            <a:r>
-              <a:rPr lang="en-US" altLang="en-US" sz="1800"/>
-              <a:t>Scenario 2:</a:t>
-            </a:r>
-            <a:endParaRPr lang="en-US" altLang="en-US" sz="1800"/>
-          </a:p>
-          <a:p>
-            <a:pPr marL="0" indent="0">
-              <a:buNone/>
-            </a:pPr>
-            <a:r>
-              <a:rPr lang="en-US" altLang="en-US" sz="1800"/>
-              <a:t>"Do you have Sony headphones? What's the price?"</a:t>
-            </a:r>
-            <a:endParaRPr lang="en-US" altLang="en-US" sz="1800"/>
-          </a:p>
-          <a:p>
-            <a:pPr marL="0" indent="0">
-              <a:buNone/>
-            </a:pPr>
-            <a:r>
-              <a:rPr lang="en-US" altLang="en-US" sz="1800"/>
-              <a:t>→ Aria calls lookup_product, returns price, rating, stock status, top 3 features.</a:t>
-            </a:r>
-            <a:endParaRPr lang="en-US" altLang="en-US" sz="1800"/>
-          </a:p>
-          <a:p>
-            <a:pPr marL="0" indent="0">
-              <a:buNone/>
-            </a:pPr>
-            <a:endParaRPr lang="en-US" altLang="en-US" sz="1800"/>
-          </a:p>
-          <a:p>
-            <a:pPr marL="0" indent="0">
-              <a:buNone/>
-            </a:pPr>
-            <a:r>
-              <a:rPr lang="en-US" altLang="en-US" sz="1800"/>
-              <a:t>Scenario 3:</a:t>
-            </a:r>
-            <a:endParaRPr lang="en-US" altLang="en-US" sz="1800"/>
-          </a:p>
-          <a:p>
-            <a:pPr marL="0" indent="0">
-              <a:buNone/>
-            </a:pPr>
-            <a:r>
-              <a:rPr lang="en-US" altLang="en-US" sz="1800"/>
-              <a:t>"I want to return a jacket I bought last week."</a:t>
-            </a:r>
-            <a:endParaRPr lang="en-US" altLang="en-US" sz="1800"/>
-          </a:p>
-          <a:p>
-            <a:pPr marL="0" indent="0">
-              <a:buNone/>
-            </a:pPr>
-            <a:r>
-              <a:rPr lang="en-US" altLang="en-US" sz="1800"/>
-              <a:t>→ Aria calls get_returns_policy, returns the Clothing return window (30 days) and steps to initiate.</a:t>
-            </a:r>
-            <a:endParaRPr lang="en-US" altLang="en-US" sz="1800"/>
           </a:p>
         </p:txBody>
       </p:sp>

</xml_diff>